<commit_message>
One-pager now two pages: Engagement + Off-Ramp/Exit
'node generate.js engagement' (npm run onepager) outputs a 2-page leave-behind —
Engagement & Compensation (1/2) + Off-Ramp / Exit (2/2). Engagement callout
pointer restored to '(next page)' (off-ramp always follows it now). Full deck
unchanged (24 slides).

https://claude.ai/code/session_01BHWC2bwKRSfRRWtpGYSNwZ
</commit_message>
<xml_diff>
--- a/JAL_Engagement_OnePager.pptx
+++ b/JAL_Engagement_OnePager.pptx
@@ -6,9 +6,10 @@
   </p:sldMasterIdLst>
   <p:sldIdLst>
     <p:sldId id="256" r:id="rId2"/>
+    <p:sldId id="257" r:id="rId3"/>
   </p:sldIdLst>
   <p:notesMasterIdLst>
-    <p:notesMasterId r:id="rId3"/>
+    <p:notesMasterId r:id="rId4"/>
   </p:notesMasterIdLst>
   <p:sldSz cx="12191695" cy="6858000"/>
   <p:notesSz cx="6858000" cy="12191695"/>
@@ -544,6 +545,94 @@
 </p:notes>
 </file>
 
+<file path=ppt/notesSlides/notesSlide2.xml><?xml version="1.0" encoding="utf-8"?>
+<p:notes xmlns:a="http://schemas.openxmlformats.org/drawingml/2006/main" xmlns:r="http://schemas.openxmlformats.org/officeDocument/2006/relationships" xmlns:p="http://schemas.openxmlformats.org/presentationml/2006/main">
+  <p:cSld>
+    <p:spTree>
+      <p:nvGrpSpPr>
+        <p:cNvPr id="1" name=""/>
+        <p:cNvGrpSpPr/>
+        <p:nvPr/>
+      </p:nvGrpSpPr>
+      <p:grpSpPr>
+        <a:xfrm>
+          <a:off x="0" y="0"/>
+          <a:ext cx="0" cy="0"/>
+          <a:chOff x="0" y="0"/>
+          <a:chExt cx="0" cy="0"/>
+        </a:xfrm>
+      </p:grpSpPr>
+      <p:sp>
+        <p:nvSpPr>
+          <p:cNvPr id="2" name="Slide Image Placeholder 1"/>
+          <p:cNvSpPr>
+            <a:spLocks noGrp="1" noRot="1" noChangeAspect="1"/>
+          </p:cNvSpPr>
+          <p:nvPr>
+            <p:ph type="sldImg"/>
+          </p:nvPr>
+        </p:nvSpPr>
+        <p:spPr/>
+      </p:sp>
+      <p:sp>
+        <p:nvSpPr>
+          <p:cNvPr id="3" name="Notes Placeholder 2"/>
+          <p:cNvSpPr>
+            <a:spLocks noGrp="1"/>
+          </p:cNvSpPr>
+          <p:nvPr>
+            <p:ph type="body" idx="1"/>
+          </p:nvPr>
+        </p:nvSpPr>
+        <p:spPr/>
+        <p:txBody>
+          <a:bodyPr/>
+          <a:lstStyle/>
+          <a:p>
+            <a:r>
+              <a:rPr lang="en-US" dirty="0"/>
+              <a:t>Directly answers Bob's email ('how do I get rid of you if you are not working out — I always look at worst case'). A clean, fast off-ramp: 30-day terminate-for-convenience on the advisory; placement fees only on capital actually placed (+6-mo tail); carry only on parcels already closed / under contract (for cause → forfeit all unrealized + clawback for fraud); co-invest returned at NAV (it's an investment, not comp); optional buyout of vested carry for a clean break. The whole point: comp is mostly contingent, so 'getting rid of me' costs only value already created.</a:t>
+            </a:r>
+            <a:endParaRPr lang="en-US" dirty="0"/>
+          </a:p>
+        </p:txBody>
+      </p:sp>
+      <p:sp>
+        <p:nvSpPr>
+          <p:cNvPr id="4" name="Slide Number Placeholder 3"/>
+          <p:cNvSpPr>
+            <a:spLocks noGrp="1"/>
+          </p:cNvSpPr>
+          <p:nvPr>
+            <p:ph type="sldNum" sz="quarter" idx="10"/>
+          </p:nvPr>
+        </p:nvSpPr>
+        <p:spPr/>
+        <p:txBody>
+          <a:bodyPr/>
+          <a:lstStyle/>
+          <a:p>
+            <a:fld id="{F7021451-1387-4CA6-816F-3879F97B5CBC}" type="slidenum">
+              <a:rPr lang="en-US"/>
+              <a:t>2</a:t>
+            </a:fld>
+            <a:endParaRPr lang="en-US"/>
+          </a:p>
+        </p:txBody>
+      </p:sp>
+    </p:spTree>
+    <p:extLst>
+      <p:ext uri="{BB962C8B-B14F-4D97-AF65-F5344CB8AC3E}">
+        <p14:creationId xmlns:p14="http://schemas.microsoft.com/office/powerpoint/2010/main" val="1024086991"/>
+      </p:ext>
+    </p:extLst>
+  </p:cSld>
+  <p:clrMapOvr>
+    <a:masterClrMapping/>
+  </p:clrMapOvr>
+</p:notes>
+</file>
+
 <file path=ppt/slideLayouts/slideLayout1.xml><?xml version="1.0" encoding="utf-8"?>
 <p:sldLayout xmlns:a="http://schemas.openxmlformats.org/drawingml/2006/main" xmlns:r="http://schemas.openxmlformats.org/officeDocument/2006/relationships" xmlns:p="http://schemas.openxmlformats.org/presentationml/2006/main" preserve="1">
   <p:cSld name="DEFAULT">
@@ -1065,7 +1154,7 @@
                 <a:ea typeface="DM Sans" pitchFamily="34" charset="-122"/>
                 <a:cs typeface="DM Sans" pitchFamily="34" charset="-120"/>
               </a:rPr>
-              <a:t>1 / 1</a:t>
+              <a:t>1 / 2</a:t>
             </a:r>
             <a:endParaRPr lang="en-US" sz="800" dirty="0"/>
           </a:p>
@@ -2543,7 +2632,1674 @@
                 <a:ea typeface="DM Sans" pitchFamily="34" charset="-122"/>
                 <a:cs typeface="DM Sans" pitchFamily="34" charset="-120"/>
               </a:rPr>
-              <a:t>Aligned, not double-dipping — most of the ~$2.7M is the contingent carry. And if it's not working, there's a clean off-ramp (on request).</a:t>
+              <a:t>Aligned, not double-dipping — most of the ~$2.7M is the contingent carry. And if it's not working, there's a clean off-ramp (next page).</a:t>
+            </a:r>
+            <a:endParaRPr lang="en-US" sz="1100" dirty="0"/>
+          </a:p>
+        </p:txBody>
+      </p:sp>
+    </p:spTree>
+  </p:cSld>
+  <p:clrMapOvr>
+    <a:masterClrMapping/>
+  </p:clrMapOvr>
+</p:sld>
+</file>
+
+<file path=ppt/slides/slide2.xml><?xml version="1.0" encoding="utf-8"?>
+<p:sld xmlns:a="http://schemas.openxmlformats.org/drawingml/2006/main" xmlns:r="http://schemas.openxmlformats.org/officeDocument/2006/relationships" xmlns:p="http://schemas.openxmlformats.org/presentationml/2006/main">
+  <p:cSld name="Slide 2">
+    <p:bg>
+      <p:bgPr>
+        <a:solidFill>
+          <a:srgbClr val="F4F2ED"/>
+        </a:solidFill>
+      </p:bgPr>
+    </p:bg>
+    <p:spTree>
+      <p:nvGrpSpPr>
+        <p:cNvPr id="1" name=""/>
+        <p:cNvGrpSpPr/>
+        <p:nvPr/>
+      </p:nvGrpSpPr>
+      <p:grpSpPr>
+        <a:xfrm>
+          <a:off x="0" y="0"/>
+          <a:ext cx="0" cy="0"/>
+          <a:chOff x="0" y="0"/>
+          <a:chExt cx="0" cy="0"/>
+        </a:xfrm>
+      </p:grpSpPr>
+      <p:sp>
+        <p:nvSpPr>
+          <p:cNvPr id="2" name="Shape 0"/>
+          <p:cNvSpPr/>
+          <p:nvPr/>
+        </p:nvSpPr>
+        <p:spPr>
+          <a:xfrm>
+            <a:off x="0" y="0"/>
+            <a:ext cx="12191695" cy="36576"/>
+          </a:xfrm>
+          <a:prstGeom prst="rect">
+            <a:avLst/>
+          </a:prstGeom>
+          <a:solidFill>
+            <a:srgbClr val="0B163C"/>
+          </a:solidFill>
+          <a:ln/>
+        </p:spPr>
+      </p:sp>
+      <p:sp>
+        <p:nvSpPr>
+          <p:cNvPr id="3" name="Text 1"/>
+          <p:cNvSpPr/>
+          <p:nvPr/>
+        </p:nvSpPr>
+        <p:spPr>
+          <a:xfrm>
+            <a:off x="457200" y="109728"/>
+            <a:ext cx="2743200" cy="274320"/>
+          </a:xfrm>
+          <a:prstGeom prst="rect">
+            <a:avLst/>
+          </a:prstGeom>
+          <a:noFill/>
+          <a:ln/>
+        </p:spPr>
+        <p:txBody>
+          <a:bodyPr wrap="square" lIns="0" tIns="0" rIns="0" bIns="0" rtlCol="0" anchor="ctr"/>
+          <a:lstStyle/>
+          <a:p>
+            <a:pPr algn="l" indent="0" marL="0">
+              <a:buNone/>
+            </a:pPr>
+            <a:r>
+              <a:rPr lang="en-US" sz="900" b="1" spc="300" kern="0" dirty="0">
+                <a:solidFill>
+                  <a:srgbClr val="0B163C"/>
+                </a:solidFill>
+                <a:latin typeface="Montserrat" pitchFamily="34" charset="0"/>
+                <a:ea typeface="Montserrat" pitchFamily="34" charset="-122"/>
+                <a:cs typeface="Montserrat" pitchFamily="34" charset="-120"/>
+              </a:rPr>
+              <a:t>JAL STRATEGIES</a:t>
+            </a:r>
+            <a:endParaRPr lang="en-US" sz="900" dirty="0"/>
+          </a:p>
+        </p:txBody>
+      </p:sp>
+      <p:sp>
+        <p:nvSpPr>
+          <p:cNvPr id="4" name="Text 2"/>
+          <p:cNvSpPr/>
+          <p:nvPr/>
+        </p:nvSpPr>
+        <p:spPr>
+          <a:xfrm>
+            <a:off x="5486400" y="109728"/>
+            <a:ext cx="6245352" cy="274320"/>
+          </a:xfrm>
+          <a:prstGeom prst="rect">
+            <a:avLst/>
+          </a:prstGeom>
+          <a:noFill/>
+          <a:ln/>
+        </p:spPr>
+        <p:txBody>
+          <a:bodyPr wrap="square" lIns="0" tIns="0" rIns="0" bIns="0" rtlCol="0" anchor="ctr"/>
+          <a:lstStyle/>
+          <a:p>
+            <a:pPr algn="r" indent="0" marL="0">
+              <a:buNone/>
+            </a:pPr>
+            <a:r>
+              <a:rPr lang="en-US" sz="900" spc="200" kern="0" dirty="0">
+                <a:solidFill>
+                  <a:srgbClr val="6B5A6B"/>
+                </a:solidFill>
+                <a:latin typeface="Montserrat" pitchFamily="34" charset="0"/>
+                <a:ea typeface="Montserrat" pitchFamily="34" charset="-122"/>
+                <a:cs typeface="Montserrat" pitchFamily="34" charset="-120"/>
+              </a:rPr>
+              <a:t>QUEENSTOWN HARBOR  ·  CONFIDENTIAL  ·  DISCUSSION DRAFT</a:t>
+            </a:r>
+            <a:endParaRPr lang="en-US" sz="900" dirty="0"/>
+          </a:p>
+        </p:txBody>
+      </p:sp>
+      <p:sp>
+        <p:nvSpPr>
+          <p:cNvPr id="5" name="Shape 3"/>
+          <p:cNvSpPr/>
+          <p:nvPr/>
+        </p:nvSpPr>
+        <p:spPr>
+          <a:xfrm>
+            <a:off x="457200" y="6446520"/>
+            <a:ext cx="11274552" cy="12802"/>
+          </a:xfrm>
+          <a:prstGeom prst="rect">
+            <a:avLst/>
+          </a:prstGeom>
+          <a:solidFill>
+            <a:srgbClr val="C4B8C4"/>
+          </a:solidFill>
+          <a:ln/>
+        </p:spPr>
+      </p:sp>
+      <p:sp>
+        <p:nvSpPr>
+          <p:cNvPr id="6" name="Text 4"/>
+          <p:cNvSpPr/>
+          <p:nvPr/>
+        </p:nvSpPr>
+        <p:spPr>
+          <a:xfrm>
+            <a:off x="457200" y="6537960"/>
+            <a:ext cx="8229600" cy="274320"/>
+          </a:xfrm>
+          <a:prstGeom prst="rect">
+            <a:avLst/>
+          </a:prstGeom>
+          <a:noFill/>
+          <a:ln/>
+        </p:spPr>
+        <p:txBody>
+          <a:bodyPr wrap="square" lIns="0" tIns="0" rIns="0" bIns="0" rtlCol="0" anchor="ctr"/>
+          <a:lstStyle/>
+          <a:p>
+            <a:pPr algn="l" indent="0" marL="0">
+              <a:buNone/>
+            </a:pPr>
+            <a:r>
+              <a:rPr lang="en-US" sz="800" dirty="0">
+                <a:solidFill>
+                  <a:srgbClr val="6B5A6B"/>
+                </a:solidFill>
+                <a:latin typeface="DM Sans" pitchFamily="34" charset="0"/>
+                <a:ea typeface="DM Sans" pitchFamily="34" charset="-122"/>
+                <a:cs typeface="DM Sans" pitchFamily="34" charset="-120"/>
+              </a:rPr>
+              <a:t>JAL Strategies  |  Justin A. Levine, Founder &amp; CEO  |  jlevine@jalstrategies.com</a:t>
+            </a:r>
+            <a:endParaRPr lang="en-US" sz="800" dirty="0"/>
+          </a:p>
+        </p:txBody>
+      </p:sp>
+      <p:sp>
+        <p:nvSpPr>
+          <p:cNvPr id="7" name="Text 5"/>
+          <p:cNvSpPr/>
+          <p:nvPr/>
+        </p:nvSpPr>
+        <p:spPr>
+          <a:xfrm>
+            <a:off x="10972800" y="6537960"/>
+            <a:ext cx="758952" cy="274320"/>
+          </a:xfrm>
+          <a:prstGeom prst="rect">
+            <a:avLst/>
+          </a:prstGeom>
+          <a:noFill/>
+          <a:ln/>
+        </p:spPr>
+        <p:txBody>
+          <a:bodyPr wrap="square" lIns="0" tIns="0" rIns="0" bIns="0" rtlCol="0" anchor="ctr"/>
+          <a:lstStyle/>
+          <a:p>
+            <a:pPr algn="r" indent="0" marL="0">
+              <a:buNone/>
+            </a:pPr>
+            <a:r>
+              <a:rPr lang="en-US" sz="800" dirty="0">
+                <a:solidFill>
+                  <a:srgbClr val="6B5A6B"/>
+                </a:solidFill>
+                <a:latin typeface="DM Sans" pitchFamily="34" charset="0"/>
+                <a:ea typeface="DM Sans" pitchFamily="34" charset="-122"/>
+                <a:cs typeface="DM Sans" pitchFamily="34" charset="-120"/>
+              </a:rPr>
+              <a:t>2 / 2</a:t>
+            </a:r>
+            <a:endParaRPr lang="en-US" sz="800" dirty="0"/>
+          </a:p>
+        </p:txBody>
+      </p:sp>
+      <p:sp>
+        <p:nvSpPr>
+          <p:cNvPr id="8" name="Text 6"/>
+          <p:cNvSpPr/>
+          <p:nvPr/>
+        </p:nvSpPr>
+        <p:spPr>
+          <a:xfrm>
+            <a:off x="457200" y="457200"/>
+            <a:ext cx="8229600" cy="274320"/>
+          </a:xfrm>
+          <a:prstGeom prst="rect">
+            <a:avLst/>
+          </a:prstGeom>
+          <a:noFill/>
+          <a:ln/>
+        </p:spPr>
+        <p:txBody>
+          <a:bodyPr wrap="square" lIns="0" tIns="0" rIns="0" bIns="0" rtlCol="0" anchor="ctr"/>
+          <a:lstStyle/>
+          <a:p>
+            <a:pPr algn="l" indent="0" marL="0">
+              <a:buNone/>
+            </a:pPr>
+            <a:r>
+              <a:rPr lang="en-US" sz="1000" b="1" spc="600" kern="0" dirty="0">
+                <a:solidFill>
+                  <a:srgbClr val="3A243A"/>
+                </a:solidFill>
+                <a:latin typeface="Montserrat" pitchFamily="34" charset="0"/>
+                <a:ea typeface="Montserrat" pitchFamily="34" charset="-122"/>
+                <a:cs typeface="Montserrat" pitchFamily="34" charset="-120"/>
+              </a:rPr>
+              <a:t>THE OFF-RAMP  ·  FOR DISCUSSION</a:t>
+            </a:r>
+            <a:endParaRPr lang="en-US" sz="1000" dirty="0"/>
+          </a:p>
+        </p:txBody>
+      </p:sp>
+      <p:sp>
+        <p:nvSpPr>
+          <p:cNvPr id="9" name="Text 7"/>
+          <p:cNvSpPr/>
+          <p:nvPr/>
+        </p:nvSpPr>
+        <p:spPr>
+          <a:xfrm>
+            <a:off x="457200" y="768096"/>
+            <a:ext cx="11274552" cy="548640"/>
+          </a:xfrm>
+          <a:prstGeom prst="rect">
+            <a:avLst/>
+          </a:prstGeom>
+          <a:noFill/>
+          <a:ln/>
+        </p:spPr>
+        <p:txBody>
+          <a:bodyPr wrap="square" lIns="0" tIns="0" rIns="0" bIns="0" rtlCol="0" anchor="ctr"/>
+          <a:lstStyle/>
+          <a:p>
+            <a:pPr algn="l" indent="0" marL="0">
+              <a:buNone/>
+            </a:pPr>
+            <a:r>
+              <a:rPr lang="en-US" sz="2500" b="1" dirty="0">
+                <a:solidFill>
+                  <a:srgbClr val="0B163C"/>
+                </a:solidFill>
+                <a:latin typeface="Montserrat" pitchFamily="34" charset="0"/>
+                <a:ea typeface="Montserrat" pitchFamily="34" charset="-122"/>
+                <a:cs typeface="Montserrat" pitchFamily="34" charset="-120"/>
+              </a:rPr>
+              <a:t>If it's not working — how you exit me.</a:t>
+            </a:r>
+            <a:endParaRPr lang="en-US" sz="2500" dirty="0"/>
+          </a:p>
+        </p:txBody>
+      </p:sp>
+      <p:sp>
+        <p:nvSpPr>
+          <p:cNvPr id="10" name="Text 8"/>
+          <p:cNvSpPr/>
+          <p:nvPr/>
+        </p:nvSpPr>
+        <p:spPr>
+          <a:xfrm>
+            <a:off x="457200" y="1335024"/>
+            <a:ext cx="11274552" cy="457200"/>
+          </a:xfrm>
+          <a:prstGeom prst="rect">
+            <a:avLst/>
+          </a:prstGeom>
+          <a:noFill/>
+          <a:ln/>
+        </p:spPr>
+        <p:txBody>
+          <a:bodyPr wrap="square" lIns="0" tIns="0" rIns="0" bIns="0" rtlCol="0" anchor="ctr"/>
+          <a:lstStyle/>
+          <a:p>
+            <a:pPr algn="l" indent="0" marL="0">
+              <a:lnSpc>
+                <a:spcPts val="1600"/>
+              </a:lnSpc>
+              <a:buNone/>
+            </a:pPr>
+            <a:r>
+              <a:rPr lang="en-US" sz="1300" dirty="0">
+                <a:solidFill>
+                  <a:srgbClr val="6B5A6B"/>
+                </a:solidFill>
+                <a:latin typeface="DM Sans" pitchFamily="34" charset="0"/>
+                <a:ea typeface="DM Sans" pitchFamily="34" charset="-122"/>
+                <a:cs typeface="DM Sans" pitchFamily="34" charset="-120"/>
+              </a:rPr>
+              <a:t>You asked the right question. Worst case, in plain terms: an easy, fast off-ramp where you only ever owe me for value already created — because my pay is mostly contingent carry.</a:t>
+            </a:r>
+            <a:endParaRPr lang="en-US" sz="1300" dirty="0"/>
+          </a:p>
+        </p:txBody>
+      </p:sp>
+      <p:sp>
+        <p:nvSpPr>
+          <p:cNvPr id="11" name="Shape 9"/>
+          <p:cNvSpPr/>
+          <p:nvPr/>
+        </p:nvSpPr>
+        <p:spPr>
+          <a:xfrm>
+            <a:off x="457200" y="1783080"/>
+            <a:ext cx="11274552" cy="786384"/>
+          </a:xfrm>
+          <a:prstGeom prst="rect">
+            <a:avLst/>
+          </a:prstGeom>
+          <a:solidFill>
+            <a:srgbClr val="0B163C"/>
+          </a:solidFill>
+          <a:ln/>
+        </p:spPr>
+      </p:sp>
+      <p:sp>
+        <p:nvSpPr>
+          <p:cNvPr id="12" name="Shape 10"/>
+          <p:cNvSpPr/>
+          <p:nvPr/>
+        </p:nvSpPr>
+        <p:spPr>
+          <a:xfrm>
+            <a:off x="457200" y="1783080"/>
+            <a:ext cx="109728" cy="786384"/>
+          </a:xfrm>
+          <a:prstGeom prst="rect">
+            <a:avLst/>
+          </a:prstGeom>
+          <a:solidFill>
+            <a:srgbClr val="3A243A"/>
+          </a:solidFill>
+          <a:ln/>
+        </p:spPr>
+      </p:sp>
+      <p:sp>
+        <p:nvSpPr>
+          <p:cNvPr id="13" name="Text 11"/>
+          <p:cNvSpPr/>
+          <p:nvPr/>
+        </p:nvSpPr>
+        <p:spPr>
+          <a:xfrm>
+            <a:off x="777240" y="1847088"/>
+            <a:ext cx="3291840" cy="658368"/>
+          </a:xfrm>
+          <a:prstGeom prst="rect">
+            <a:avLst/>
+          </a:prstGeom>
+          <a:noFill/>
+          <a:ln/>
+        </p:spPr>
+        <p:txBody>
+          <a:bodyPr wrap="square" lIns="0" tIns="0" rIns="0" bIns="0" rtlCol="0" anchor="ctr"/>
+          <a:lstStyle/>
+          <a:p>
+            <a:pPr algn="l" indent="0" marL="0">
+              <a:buNone/>
+            </a:pPr>
+            <a:r>
+              <a:rPr lang="en-US" sz="2400" b="1" dirty="0">
+                <a:solidFill>
+                  <a:srgbClr val="C4B8C4"/>
+                </a:solidFill>
+                <a:latin typeface="Montserrat" pitchFamily="34" charset="0"/>
+                <a:ea typeface="Montserrat" pitchFamily="34" charset="-122"/>
+                <a:cs typeface="Montserrat" pitchFamily="34" charset="-120"/>
+              </a:rPr>
+              <a:t>30-day notice</a:t>
+            </a:r>
+            <a:endParaRPr lang="en-US" sz="2400" dirty="0"/>
+          </a:p>
+        </p:txBody>
+      </p:sp>
+      <p:sp>
+        <p:nvSpPr>
+          <p:cNvPr id="14" name="Text 12"/>
+          <p:cNvSpPr/>
+          <p:nvPr/>
+        </p:nvSpPr>
+        <p:spPr>
+          <a:xfrm>
+            <a:off x="4114800" y="1783080"/>
+            <a:ext cx="4572000" cy="786384"/>
+          </a:xfrm>
+          <a:prstGeom prst="rect">
+            <a:avLst/>
+          </a:prstGeom>
+          <a:noFill/>
+          <a:ln/>
+        </p:spPr>
+        <p:txBody>
+          <a:bodyPr wrap="square" lIns="0" tIns="0" rIns="0" bIns="0" rtlCol="0" anchor="ctr"/>
+          <a:lstStyle/>
+          <a:p>
+            <a:pPr algn="l" indent="0" marL="0">
+              <a:lnSpc>
+                <a:spcPts val="1600"/>
+              </a:lnSpc>
+              <a:buNone/>
+            </a:pPr>
+            <a:r>
+              <a:rPr lang="en-US" sz="1300" b="1" dirty="0">
+                <a:solidFill>
+                  <a:srgbClr val="FFFFFF"/>
+                </a:solidFill>
+                <a:latin typeface="Montserrat" pitchFamily="34" charset="0"/>
+                <a:ea typeface="Montserrat" pitchFamily="34" charset="-122"/>
+                <a:cs typeface="Montserrat" pitchFamily="34" charset="-120"/>
+              </a:rPr>
+              <a:t>Terminate for convenience — either side, no reason needed.</a:t>
+            </a:r>
+            <a:endParaRPr lang="en-US" sz="1300" dirty="0"/>
+          </a:p>
+        </p:txBody>
+      </p:sp>
+      <p:sp>
+        <p:nvSpPr>
+          <p:cNvPr id="15" name="Text 13"/>
+          <p:cNvSpPr/>
+          <p:nvPr/>
+        </p:nvSpPr>
+        <p:spPr>
+          <a:xfrm>
+            <a:off x="8778240" y="1783080"/>
+            <a:ext cx="2953512" cy="786384"/>
+          </a:xfrm>
+          <a:prstGeom prst="rect">
+            <a:avLst/>
+          </a:prstGeom>
+          <a:noFill/>
+          <a:ln/>
+        </p:spPr>
+        <p:txBody>
+          <a:bodyPr wrap="square" lIns="25400" tIns="76200" rIns="127000" bIns="25400" rtlCol="0" anchor="ctr"/>
+          <a:lstStyle/>
+          <a:p>
+            <a:pPr algn="r" indent="0" marL="0">
+              <a:lnSpc>
+                <a:spcPts val="1500"/>
+              </a:lnSpc>
+              <a:buNone/>
+            </a:pPr>
+            <a:r>
+              <a:rPr lang="en-US" sz="1300" b="1" dirty="0">
+                <a:solidFill>
+                  <a:srgbClr val="8C9BB5"/>
+                </a:solidFill>
+                <a:latin typeface="Montserrat" pitchFamily="34" charset="0"/>
+                <a:ea typeface="Montserrat" pitchFamily="34" charset="-122"/>
+                <a:cs typeface="Montserrat" pitchFamily="34" charset="-120"/>
+              </a:rPr>
+              <a:t>Worst</a:t>
+            </a:r>
+            <a:endParaRPr lang="en-US" sz="1300" dirty="0"/>
+          </a:p>
+          <a:p>
+            <a:pPr algn="r" indent="0" marL="0">
+              <a:lnSpc>
+                <a:spcPts val="1500"/>
+              </a:lnSpc>
+              <a:buNone/>
+            </a:pPr>
+            <a:r>
+              <a:rPr lang="en-US" sz="1300" b="1" dirty="0">
+                <a:solidFill>
+                  <a:srgbClr val="8C9BB5"/>
+                </a:solidFill>
+                <a:latin typeface="Montserrat" pitchFamily="34" charset="0"/>
+                <a:ea typeface="Montserrat" pitchFamily="34" charset="-122"/>
+                <a:cs typeface="Montserrat" pitchFamily="34" charset="-120"/>
+              </a:rPr>
+              <a:t>case</a:t>
+            </a:r>
+            <a:endParaRPr lang="en-US" sz="1300" dirty="0"/>
+          </a:p>
+        </p:txBody>
+      </p:sp>
+      <p:sp>
+        <p:nvSpPr>
+          <p:cNvPr id="16" name="Shape 14"/>
+          <p:cNvSpPr/>
+          <p:nvPr/>
+        </p:nvSpPr>
+        <p:spPr>
+          <a:xfrm>
+            <a:off x="457200" y="2697480"/>
+            <a:ext cx="2331720" cy="365760"/>
+          </a:xfrm>
+          <a:prstGeom prst="rect">
+            <a:avLst/>
+          </a:prstGeom>
+          <a:solidFill>
+            <a:srgbClr val="0B163C"/>
+          </a:solidFill>
+          <a:ln/>
+        </p:spPr>
+      </p:sp>
+      <p:sp>
+        <p:nvSpPr>
+          <p:cNvPr id="17" name="Text 15"/>
+          <p:cNvSpPr/>
+          <p:nvPr/>
+        </p:nvSpPr>
+        <p:spPr>
+          <a:xfrm>
+            <a:off x="457200" y="2697480"/>
+            <a:ext cx="2331720" cy="365760"/>
+          </a:xfrm>
+          <a:prstGeom prst="rect">
+            <a:avLst/>
+          </a:prstGeom>
+          <a:noFill/>
+          <a:ln/>
+        </p:spPr>
+        <p:txBody>
+          <a:bodyPr wrap="square" lIns="25400" tIns="76200" rIns="76200" bIns="25400" rtlCol="0" anchor="ctr"/>
+          <a:lstStyle/>
+          <a:p>
+            <a:pPr algn="l" indent="0" marL="0">
+              <a:buNone/>
+            </a:pPr>
+            <a:r>
+              <a:rPr lang="en-US" sz="900" b="1" dirty="0">
+                <a:solidFill>
+                  <a:srgbClr val="FFFFFF"/>
+                </a:solidFill>
+                <a:latin typeface="Montserrat" pitchFamily="34" charset="0"/>
+                <a:ea typeface="Montserrat" pitchFamily="34" charset="-122"/>
+                <a:cs typeface="Montserrat" pitchFamily="34" charset="-120"/>
+              </a:rPr>
+              <a:t>If we part ways</a:t>
+            </a:r>
+            <a:endParaRPr lang="en-US" sz="900" dirty="0"/>
+          </a:p>
+        </p:txBody>
+      </p:sp>
+      <p:sp>
+        <p:nvSpPr>
+          <p:cNvPr id="18" name="Shape 16"/>
+          <p:cNvSpPr/>
+          <p:nvPr/>
+        </p:nvSpPr>
+        <p:spPr>
+          <a:xfrm>
+            <a:off x="2788920" y="2697480"/>
+            <a:ext cx="2606040" cy="365760"/>
+          </a:xfrm>
+          <a:prstGeom prst="rect">
+            <a:avLst/>
+          </a:prstGeom>
+          <a:solidFill>
+            <a:srgbClr val="0B163C"/>
+          </a:solidFill>
+          <a:ln/>
+        </p:spPr>
+      </p:sp>
+      <p:sp>
+        <p:nvSpPr>
+          <p:cNvPr id="19" name="Text 17"/>
+          <p:cNvSpPr/>
+          <p:nvPr/>
+        </p:nvSpPr>
+        <p:spPr>
+          <a:xfrm>
+            <a:off x="2788920" y="2697480"/>
+            <a:ext cx="2606040" cy="365760"/>
+          </a:xfrm>
+          <a:prstGeom prst="rect">
+            <a:avLst/>
+          </a:prstGeom>
+          <a:noFill/>
+          <a:ln/>
+        </p:spPr>
+        <p:txBody>
+          <a:bodyPr wrap="square" lIns="25400" tIns="76200" rIns="76200" bIns="25400" rtlCol="0" anchor="ctr"/>
+          <a:lstStyle/>
+          <a:p>
+            <a:pPr algn="ctr" indent="0" marL="0">
+              <a:buNone/>
+            </a:pPr>
+            <a:r>
+              <a:rPr lang="en-US" sz="900" b="1" dirty="0">
+                <a:solidFill>
+                  <a:srgbClr val="FFFFFF"/>
+                </a:solidFill>
+                <a:latin typeface="Montserrat" pitchFamily="34" charset="0"/>
+                <a:ea typeface="Montserrat" pitchFamily="34" charset="-122"/>
+                <a:cs typeface="Montserrat" pitchFamily="34" charset="-120"/>
+              </a:rPr>
+              <a:t>Terms</a:t>
+            </a:r>
+            <a:endParaRPr lang="en-US" sz="900" dirty="0"/>
+          </a:p>
+        </p:txBody>
+      </p:sp>
+      <p:sp>
+        <p:nvSpPr>
+          <p:cNvPr id="20" name="Shape 18"/>
+          <p:cNvSpPr/>
+          <p:nvPr/>
+        </p:nvSpPr>
+        <p:spPr>
+          <a:xfrm>
+            <a:off x="5394960" y="2697480"/>
+            <a:ext cx="6336792" cy="365760"/>
+          </a:xfrm>
+          <a:prstGeom prst="rect">
+            <a:avLst/>
+          </a:prstGeom>
+          <a:solidFill>
+            <a:srgbClr val="0B163C"/>
+          </a:solidFill>
+          <a:ln/>
+        </p:spPr>
+      </p:sp>
+      <p:sp>
+        <p:nvSpPr>
+          <p:cNvPr id="21" name="Text 19"/>
+          <p:cNvSpPr/>
+          <p:nvPr/>
+        </p:nvSpPr>
+        <p:spPr>
+          <a:xfrm>
+            <a:off x="5394960" y="2697480"/>
+            <a:ext cx="6336792" cy="365760"/>
+          </a:xfrm>
+          <a:prstGeom prst="rect">
+            <a:avLst/>
+          </a:prstGeom>
+          <a:noFill/>
+          <a:ln/>
+        </p:spPr>
+        <p:txBody>
+          <a:bodyPr wrap="square" lIns="25400" tIns="76200" rIns="76200" bIns="25400" rtlCol="0" anchor="ctr"/>
+          <a:lstStyle/>
+          <a:p>
+            <a:pPr algn="l" indent="0" marL="0">
+              <a:buNone/>
+            </a:pPr>
+            <a:r>
+              <a:rPr lang="en-US" sz="900" b="1" dirty="0">
+                <a:solidFill>
+                  <a:srgbClr val="FFFFFF"/>
+                </a:solidFill>
+                <a:latin typeface="Montserrat" pitchFamily="34" charset="0"/>
+                <a:ea typeface="Montserrat" pitchFamily="34" charset="-122"/>
+                <a:cs typeface="Montserrat" pitchFamily="34" charset="-120"/>
+              </a:rPr>
+              <a:t>What happens</a:t>
+            </a:r>
+            <a:endParaRPr lang="en-US" sz="900" dirty="0"/>
+          </a:p>
+        </p:txBody>
+      </p:sp>
+      <p:sp>
+        <p:nvSpPr>
+          <p:cNvPr id="22" name="Shape 20"/>
+          <p:cNvSpPr/>
+          <p:nvPr/>
+        </p:nvSpPr>
+        <p:spPr>
+          <a:xfrm>
+            <a:off x="457200" y="3063240"/>
+            <a:ext cx="2331720" cy="566928"/>
+          </a:xfrm>
+          <a:prstGeom prst="rect">
+            <a:avLst/>
+          </a:prstGeom>
+          <a:solidFill>
+            <a:srgbClr val="FFFFFF"/>
+          </a:solidFill>
+          <a:ln/>
+        </p:spPr>
+      </p:sp>
+      <p:sp>
+        <p:nvSpPr>
+          <p:cNvPr id="23" name="Text 21"/>
+          <p:cNvSpPr/>
+          <p:nvPr/>
+        </p:nvSpPr>
+        <p:spPr>
+          <a:xfrm>
+            <a:off x="457200" y="3063240"/>
+            <a:ext cx="2331720" cy="566928"/>
+          </a:xfrm>
+          <a:prstGeom prst="rect">
+            <a:avLst/>
+          </a:prstGeom>
+          <a:noFill/>
+          <a:ln/>
+        </p:spPr>
+        <p:txBody>
+          <a:bodyPr wrap="square" lIns="25400" tIns="76200" rIns="76200" bIns="25400" rtlCol="0" anchor="ctr"/>
+          <a:lstStyle/>
+          <a:p>
+            <a:pPr algn="l" indent="0" marL="0">
+              <a:buNone/>
+            </a:pPr>
+            <a:r>
+              <a:rPr lang="en-US" sz="1100" b="1" dirty="0">
+                <a:solidFill>
+                  <a:srgbClr val="0B163C"/>
+                </a:solidFill>
+                <a:latin typeface="Montserrat" pitchFamily="34" charset="0"/>
+                <a:ea typeface="Montserrat" pitchFamily="34" charset="-122"/>
+                <a:cs typeface="Montserrat" pitchFamily="34" charset="-120"/>
+              </a:rPr>
+              <a:t>Advisory role</a:t>
+            </a:r>
+            <a:endParaRPr lang="en-US" sz="1100" dirty="0"/>
+          </a:p>
+        </p:txBody>
+      </p:sp>
+      <p:sp>
+        <p:nvSpPr>
+          <p:cNvPr id="24" name="Shape 22"/>
+          <p:cNvSpPr/>
+          <p:nvPr/>
+        </p:nvSpPr>
+        <p:spPr>
+          <a:xfrm>
+            <a:off x="2788920" y="3063240"/>
+            <a:ext cx="2606040" cy="566928"/>
+          </a:xfrm>
+          <a:prstGeom prst="rect">
+            <a:avLst/>
+          </a:prstGeom>
+          <a:solidFill>
+            <a:srgbClr val="FFFFFF"/>
+          </a:solidFill>
+          <a:ln/>
+        </p:spPr>
+      </p:sp>
+      <p:sp>
+        <p:nvSpPr>
+          <p:cNvPr id="25" name="Text 23"/>
+          <p:cNvSpPr/>
+          <p:nvPr/>
+        </p:nvSpPr>
+        <p:spPr>
+          <a:xfrm>
+            <a:off x="2788920" y="3063240"/>
+            <a:ext cx="2606040" cy="566928"/>
+          </a:xfrm>
+          <a:prstGeom prst="rect">
+            <a:avLst/>
+          </a:prstGeom>
+          <a:noFill/>
+          <a:ln/>
+        </p:spPr>
+        <p:txBody>
+          <a:bodyPr wrap="square" lIns="25400" tIns="76200" rIns="76200" bIns="25400" rtlCol="0" anchor="ctr"/>
+          <a:lstStyle/>
+          <a:p>
+            <a:pPr algn="ctr" indent="0" marL="0">
+              <a:buNone/>
+            </a:pPr>
+            <a:r>
+              <a:rPr lang="en-US" sz="1000" b="1" dirty="0">
+                <a:solidFill>
+                  <a:srgbClr val="3A243A"/>
+                </a:solidFill>
+                <a:latin typeface="Montserrat" pitchFamily="34" charset="0"/>
+                <a:ea typeface="Montserrat" pitchFamily="34" charset="-122"/>
+                <a:cs typeface="Montserrat" pitchFamily="34" charset="-120"/>
+              </a:rPr>
+              <a:t>30-day notice, either side</a:t>
+            </a:r>
+            <a:endParaRPr lang="en-US" sz="1000" dirty="0"/>
+          </a:p>
+        </p:txBody>
+      </p:sp>
+      <p:sp>
+        <p:nvSpPr>
+          <p:cNvPr id="26" name="Shape 24"/>
+          <p:cNvSpPr/>
+          <p:nvPr/>
+        </p:nvSpPr>
+        <p:spPr>
+          <a:xfrm>
+            <a:off x="5394960" y="3063240"/>
+            <a:ext cx="6336792" cy="566928"/>
+          </a:xfrm>
+          <a:prstGeom prst="rect">
+            <a:avLst/>
+          </a:prstGeom>
+          <a:solidFill>
+            <a:srgbClr val="FFFFFF"/>
+          </a:solidFill>
+          <a:ln/>
+        </p:spPr>
+      </p:sp>
+      <p:sp>
+        <p:nvSpPr>
+          <p:cNvPr id="27" name="Text 25"/>
+          <p:cNvSpPr/>
+          <p:nvPr/>
+        </p:nvSpPr>
+        <p:spPr>
+          <a:xfrm>
+            <a:off x="5394960" y="3063240"/>
+            <a:ext cx="6336792" cy="566928"/>
+          </a:xfrm>
+          <a:prstGeom prst="rect">
+            <a:avLst/>
+          </a:prstGeom>
+          <a:noFill/>
+          <a:ln/>
+        </p:spPr>
+        <p:txBody>
+          <a:bodyPr wrap="square" lIns="25400" tIns="76200" rIns="76200" bIns="25400" rtlCol="0" anchor="ctr"/>
+          <a:lstStyle/>
+          <a:p>
+            <a:pPr algn="l" indent="0" marL="0">
+              <a:lnSpc>
+                <a:spcPts val="1200"/>
+              </a:lnSpc>
+              <a:buNone/>
+            </a:pPr>
+            <a:r>
+              <a:rPr lang="en-US" sz="950" dirty="0">
+                <a:solidFill>
+                  <a:srgbClr val="6B5A6B"/>
+                </a:solidFill>
+                <a:latin typeface="DM Sans" pitchFamily="34" charset="0"/>
+                <a:ea typeface="DM Sans" pitchFamily="34" charset="-122"/>
+                <a:cs typeface="DM Sans" pitchFamily="34" charset="-120"/>
+              </a:rPr>
+              <a:t>Terminate for convenience — no reason needed. Retainer + approved expenses paid through the notice date; no severance.</a:t>
+            </a:r>
+            <a:endParaRPr lang="en-US" sz="950" dirty="0"/>
+          </a:p>
+        </p:txBody>
+      </p:sp>
+      <p:sp>
+        <p:nvSpPr>
+          <p:cNvPr id="28" name="Shape 26"/>
+          <p:cNvSpPr/>
+          <p:nvPr/>
+        </p:nvSpPr>
+        <p:spPr>
+          <a:xfrm>
+            <a:off x="457200" y="3630168"/>
+            <a:ext cx="2331720" cy="566928"/>
+          </a:xfrm>
+          <a:prstGeom prst="rect">
+            <a:avLst/>
+          </a:prstGeom>
+          <a:solidFill>
+            <a:srgbClr val="F4F2ED"/>
+          </a:solidFill>
+          <a:ln/>
+        </p:spPr>
+      </p:sp>
+      <p:sp>
+        <p:nvSpPr>
+          <p:cNvPr id="29" name="Text 27"/>
+          <p:cNvSpPr/>
+          <p:nvPr/>
+        </p:nvSpPr>
+        <p:spPr>
+          <a:xfrm>
+            <a:off x="457200" y="3630168"/>
+            <a:ext cx="2331720" cy="566928"/>
+          </a:xfrm>
+          <a:prstGeom prst="rect">
+            <a:avLst/>
+          </a:prstGeom>
+          <a:noFill/>
+          <a:ln/>
+        </p:spPr>
+        <p:txBody>
+          <a:bodyPr wrap="square" lIns="25400" tIns="76200" rIns="76200" bIns="25400" rtlCol="0" anchor="ctr"/>
+          <a:lstStyle/>
+          <a:p>
+            <a:pPr algn="l" indent="0" marL="0">
+              <a:buNone/>
+            </a:pPr>
+            <a:r>
+              <a:rPr lang="en-US" sz="1100" b="1" dirty="0">
+                <a:solidFill>
+                  <a:srgbClr val="0B163C"/>
+                </a:solidFill>
+                <a:latin typeface="Montserrat" pitchFamily="34" charset="0"/>
+                <a:ea typeface="Montserrat" pitchFamily="34" charset="-122"/>
+                <a:cs typeface="Montserrat" pitchFamily="34" charset="-120"/>
+              </a:rPr>
+              <a:t>Placement fees</a:t>
+            </a:r>
+            <a:endParaRPr lang="en-US" sz="1100" dirty="0"/>
+          </a:p>
+        </p:txBody>
+      </p:sp>
+      <p:sp>
+        <p:nvSpPr>
+          <p:cNvPr id="30" name="Shape 28"/>
+          <p:cNvSpPr/>
+          <p:nvPr/>
+        </p:nvSpPr>
+        <p:spPr>
+          <a:xfrm>
+            <a:off x="2788920" y="3630168"/>
+            <a:ext cx="2606040" cy="566928"/>
+          </a:xfrm>
+          <a:prstGeom prst="rect">
+            <a:avLst/>
+          </a:prstGeom>
+          <a:solidFill>
+            <a:srgbClr val="F4F2ED"/>
+          </a:solidFill>
+          <a:ln/>
+        </p:spPr>
+      </p:sp>
+      <p:sp>
+        <p:nvSpPr>
+          <p:cNvPr id="31" name="Text 29"/>
+          <p:cNvSpPr/>
+          <p:nvPr/>
+        </p:nvSpPr>
+        <p:spPr>
+          <a:xfrm>
+            <a:off x="2788920" y="3630168"/>
+            <a:ext cx="2606040" cy="566928"/>
+          </a:xfrm>
+          <a:prstGeom prst="rect">
+            <a:avLst/>
+          </a:prstGeom>
+          <a:noFill/>
+          <a:ln/>
+        </p:spPr>
+        <p:txBody>
+          <a:bodyPr wrap="square" lIns="25400" tIns="76200" rIns="76200" bIns="25400" rtlCol="0" anchor="ctr"/>
+          <a:lstStyle/>
+          <a:p>
+            <a:pPr algn="ctr" indent="0" marL="0">
+              <a:buNone/>
+            </a:pPr>
+            <a:r>
+              <a:rPr lang="en-US" sz="1000" b="1" dirty="0">
+                <a:solidFill>
+                  <a:srgbClr val="3A243A"/>
+                </a:solidFill>
+                <a:latin typeface="Montserrat" pitchFamily="34" charset="0"/>
+                <a:ea typeface="Montserrat" pitchFamily="34" charset="-122"/>
+                <a:cs typeface="Montserrat" pitchFamily="34" charset="-120"/>
+              </a:rPr>
+              <a:t>Earned + 6-mo tail</a:t>
+            </a:r>
+            <a:endParaRPr lang="en-US" sz="1000" dirty="0"/>
+          </a:p>
+        </p:txBody>
+      </p:sp>
+      <p:sp>
+        <p:nvSpPr>
+          <p:cNvPr id="32" name="Shape 30"/>
+          <p:cNvSpPr/>
+          <p:nvPr/>
+        </p:nvSpPr>
+        <p:spPr>
+          <a:xfrm>
+            <a:off x="5394960" y="3630168"/>
+            <a:ext cx="6336792" cy="566928"/>
+          </a:xfrm>
+          <a:prstGeom prst="rect">
+            <a:avLst/>
+          </a:prstGeom>
+          <a:solidFill>
+            <a:srgbClr val="F4F2ED"/>
+          </a:solidFill>
+          <a:ln/>
+        </p:spPr>
+      </p:sp>
+      <p:sp>
+        <p:nvSpPr>
+          <p:cNvPr id="33" name="Text 31"/>
+          <p:cNvSpPr/>
+          <p:nvPr/>
+        </p:nvSpPr>
+        <p:spPr>
+          <a:xfrm>
+            <a:off x="5394960" y="3630168"/>
+            <a:ext cx="6336792" cy="566928"/>
+          </a:xfrm>
+          <a:prstGeom prst="rect">
+            <a:avLst/>
+          </a:prstGeom>
+          <a:noFill/>
+          <a:ln/>
+        </p:spPr>
+        <p:txBody>
+          <a:bodyPr wrap="square" lIns="25400" tIns="76200" rIns="76200" bIns="25400" rtlCol="0" anchor="ctr"/>
+          <a:lstStyle/>
+          <a:p>
+            <a:pPr algn="l" indent="0" marL="0">
+              <a:lnSpc>
+                <a:spcPts val="1200"/>
+              </a:lnSpc>
+              <a:buNone/>
+            </a:pPr>
+            <a:r>
+              <a:rPr lang="en-US" sz="950" dirty="0">
+                <a:solidFill>
+                  <a:srgbClr val="6B5A6B"/>
+                </a:solidFill>
+                <a:latin typeface="DM Sans" pitchFamily="34" charset="0"/>
+                <a:ea typeface="DM Sans" pitchFamily="34" charset="-122"/>
+                <a:cs typeface="DM Sans" pitchFamily="34" charset="-120"/>
+              </a:rPr>
+              <a:t>Due only on capital actually placed before you let me go, plus a 6-month tail on capital I'd already sourced.</a:t>
+            </a:r>
+            <a:endParaRPr lang="en-US" sz="950" dirty="0"/>
+          </a:p>
+        </p:txBody>
+      </p:sp>
+      <p:sp>
+        <p:nvSpPr>
+          <p:cNvPr id="34" name="Shape 32"/>
+          <p:cNvSpPr/>
+          <p:nvPr/>
+        </p:nvSpPr>
+        <p:spPr>
+          <a:xfrm>
+            <a:off x="457200" y="4197096"/>
+            <a:ext cx="2331720" cy="566928"/>
+          </a:xfrm>
+          <a:prstGeom prst="rect">
+            <a:avLst/>
+          </a:prstGeom>
+          <a:solidFill>
+            <a:srgbClr val="FFFFFF"/>
+          </a:solidFill>
+          <a:ln/>
+        </p:spPr>
+      </p:sp>
+      <p:sp>
+        <p:nvSpPr>
+          <p:cNvPr id="35" name="Text 33"/>
+          <p:cNvSpPr/>
+          <p:nvPr/>
+        </p:nvSpPr>
+        <p:spPr>
+          <a:xfrm>
+            <a:off x="457200" y="4197096"/>
+            <a:ext cx="2331720" cy="566928"/>
+          </a:xfrm>
+          <a:prstGeom prst="rect">
+            <a:avLst/>
+          </a:prstGeom>
+          <a:noFill/>
+          <a:ln/>
+        </p:spPr>
+        <p:txBody>
+          <a:bodyPr wrap="square" lIns="25400" tIns="76200" rIns="76200" bIns="25400" rtlCol="0" anchor="ctr"/>
+          <a:lstStyle/>
+          <a:p>
+            <a:pPr algn="l" indent="0" marL="0">
+              <a:buNone/>
+            </a:pPr>
+            <a:r>
+              <a:rPr lang="en-US" sz="1100" b="1" dirty="0">
+                <a:solidFill>
+                  <a:srgbClr val="0B163C"/>
+                </a:solidFill>
+                <a:latin typeface="Montserrat" pitchFamily="34" charset="0"/>
+                <a:ea typeface="Montserrat" pitchFamily="34" charset="-122"/>
+                <a:cs typeface="Montserrat" pitchFamily="34" charset="-120"/>
+              </a:rPr>
+              <a:t>The carry</a:t>
+            </a:r>
+            <a:endParaRPr lang="en-US" sz="1100" dirty="0"/>
+          </a:p>
+        </p:txBody>
+      </p:sp>
+      <p:sp>
+        <p:nvSpPr>
+          <p:cNvPr id="36" name="Shape 34"/>
+          <p:cNvSpPr/>
+          <p:nvPr/>
+        </p:nvSpPr>
+        <p:spPr>
+          <a:xfrm>
+            <a:off x="2788920" y="4197096"/>
+            <a:ext cx="2606040" cy="566928"/>
+          </a:xfrm>
+          <a:prstGeom prst="rect">
+            <a:avLst/>
+          </a:prstGeom>
+          <a:solidFill>
+            <a:srgbClr val="FFFFFF"/>
+          </a:solidFill>
+          <a:ln/>
+        </p:spPr>
+      </p:sp>
+      <p:sp>
+        <p:nvSpPr>
+          <p:cNvPr id="37" name="Text 35"/>
+          <p:cNvSpPr/>
+          <p:nvPr/>
+        </p:nvSpPr>
+        <p:spPr>
+          <a:xfrm>
+            <a:off x="2788920" y="4197096"/>
+            <a:ext cx="2606040" cy="566928"/>
+          </a:xfrm>
+          <a:prstGeom prst="rect">
+            <a:avLst/>
+          </a:prstGeom>
+          <a:noFill/>
+          <a:ln/>
+        </p:spPr>
+        <p:txBody>
+          <a:bodyPr wrap="square" lIns="25400" tIns="76200" rIns="76200" bIns="25400" rtlCol="0" anchor="ctr"/>
+          <a:lstStyle/>
+          <a:p>
+            <a:pPr algn="ctr" indent="0" marL="0">
+              <a:buNone/>
+            </a:pPr>
+            <a:r>
+              <a:rPr lang="en-US" sz="1000" b="1" dirty="0">
+                <a:solidFill>
+                  <a:srgbClr val="3A243A"/>
+                </a:solidFill>
+                <a:latin typeface="Montserrat" pitchFamily="34" charset="0"/>
+                <a:ea typeface="Montserrat" pitchFamily="34" charset="-122"/>
+                <a:cs typeface="Montserrat" pitchFamily="34" charset="-120"/>
+              </a:rPr>
+              <a:t>Keep only what's earned</a:t>
+            </a:r>
+            <a:endParaRPr lang="en-US" sz="1000" dirty="0"/>
+          </a:p>
+        </p:txBody>
+      </p:sp>
+      <p:sp>
+        <p:nvSpPr>
+          <p:cNvPr id="38" name="Shape 36"/>
+          <p:cNvSpPr/>
+          <p:nvPr/>
+        </p:nvSpPr>
+        <p:spPr>
+          <a:xfrm>
+            <a:off x="5394960" y="4197096"/>
+            <a:ext cx="6336792" cy="566928"/>
+          </a:xfrm>
+          <a:prstGeom prst="rect">
+            <a:avLst/>
+          </a:prstGeom>
+          <a:solidFill>
+            <a:srgbClr val="FFFFFF"/>
+          </a:solidFill>
+          <a:ln/>
+        </p:spPr>
+      </p:sp>
+      <p:sp>
+        <p:nvSpPr>
+          <p:cNvPr id="39" name="Text 37"/>
+          <p:cNvSpPr/>
+          <p:nvPr/>
+        </p:nvSpPr>
+        <p:spPr>
+          <a:xfrm>
+            <a:off x="5394960" y="4197096"/>
+            <a:ext cx="6336792" cy="566928"/>
+          </a:xfrm>
+          <a:prstGeom prst="rect">
+            <a:avLst/>
+          </a:prstGeom>
+          <a:noFill/>
+          <a:ln/>
+        </p:spPr>
+        <p:txBody>
+          <a:bodyPr wrap="square" lIns="25400" tIns="76200" rIns="76200" bIns="25400" rtlCol="0" anchor="ctr"/>
+          <a:lstStyle/>
+          <a:p>
+            <a:pPr algn="l" indent="0" marL="0">
+              <a:lnSpc>
+                <a:spcPts val="1200"/>
+              </a:lnSpc>
+              <a:buNone/>
+            </a:pPr>
+            <a:r>
+              <a:rPr lang="en-US" sz="950" dirty="0">
+                <a:solidFill>
+                  <a:srgbClr val="6B5A6B"/>
+                </a:solidFill>
+                <a:latin typeface="DM Sans" pitchFamily="34" charset="0"/>
+                <a:ea typeface="DM Sans" pitchFamily="34" charset="-122"/>
+                <a:cs typeface="DM Sans" pitchFamily="34" charset="-120"/>
+              </a:rPr>
+              <a:t>Without cause: I keep carry on parcels already closed or under contract — speculative forfeits. For cause: forfeit all unrealized (clawback for fraud).</a:t>
+            </a:r>
+            <a:endParaRPr lang="en-US" sz="950" dirty="0"/>
+          </a:p>
+        </p:txBody>
+      </p:sp>
+      <p:sp>
+        <p:nvSpPr>
+          <p:cNvPr id="40" name="Shape 38"/>
+          <p:cNvSpPr/>
+          <p:nvPr/>
+        </p:nvSpPr>
+        <p:spPr>
+          <a:xfrm>
+            <a:off x="457200" y="4764024"/>
+            <a:ext cx="2331720" cy="566928"/>
+          </a:xfrm>
+          <a:prstGeom prst="rect">
+            <a:avLst/>
+          </a:prstGeom>
+          <a:solidFill>
+            <a:srgbClr val="F4F2ED"/>
+          </a:solidFill>
+          <a:ln/>
+        </p:spPr>
+      </p:sp>
+      <p:sp>
+        <p:nvSpPr>
+          <p:cNvPr id="41" name="Text 39"/>
+          <p:cNvSpPr/>
+          <p:nvPr/>
+        </p:nvSpPr>
+        <p:spPr>
+          <a:xfrm>
+            <a:off x="457200" y="4764024"/>
+            <a:ext cx="2331720" cy="566928"/>
+          </a:xfrm>
+          <a:prstGeom prst="rect">
+            <a:avLst/>
+          </a:prstGeom>
+          <a:noFill/>
+          <a:ln/>
+        </p:spPr>
+        <p:txBody>
+          <a:bodyPr wrap="square" lIns="25400" tIns="76200" rIns="76200" bIns="25400" rtlCol="0" anchor="ctr"/>
+          <a:lstStyle/>
+          <a:p>
+            <a:pPr algn="l" indent="0" marL="0">
+              <a:buNone/>
+            </a:pPr>
+            <a:r>
+              <a:rPr lang="en-US" sz="1100" b="1" dirty="0">
+                <a:solidFill>
+                  <a:srgbClr val="0B163C"/>
+                </a:solidFill>
+                <a:latin typeface="Montserrat" pitchFamily="34" charset="0"/>
+                <a:ea typeface="Montserrat" pitchFamily="34" charset="-122"/>
+                <a:cs typeface="Montserrat" pitchFamily="34" charset="-120"/>
+              </a:rPr>
+              <a:t>My co-invest</a:t>
+            </a:r>
+            <a:endParaRPr lang="en-US" sz="1100" dirty="0"/>
+          </a:p>
+        </p:txBody>
+      </p:sp>
+      <p:sp>
+        <p:nvSpPr>
+          <p:cNvPr id="42" name="Shape 40"/>
+          <p:cNvSpPr/>
+          <p:nvPr/>
+        </p:nvSpPr>
+        <p:spPr>
+          <a:xfrm>
+            <a:off x="2788920" y="4764024"/>
+            <a:ext cx="2606040" cy="566928"/>
+          </a:xfrm>
+          <a:prstGeom prst="rect">
+            <a:avLst/>
+          </a:prstGeom>
+          <a:solidFill>
+            <a:srgbClr val="F4F2ED"/>
+          </a:solidFill>
+          <a:ln/>
+        </p:spPr>
+      </p:sp>
+      <p:sp>
+        <p:nvSpPr>
+          <p:cNvPr id="43" name="Text 41"/>
+          <p:cNvSpPr/>
+          <p:nvPr/>
+        </p:nvSpPr>
+        <p:spPr>
+          <a:xfrm>
+            <a:off x="2788920" y="4764024"/>
+            <a:ext cx="2606040" cy="566928"/>
+          </a:xfrm>
+          <a:prstGeom prst="rect">
+            <a:avLst/>
+          </a:prstGeom>
+          <a:noFill/>
+          <a:ln/>
+        </p:spPr>
+        <p:txBody>
+          <a:bodyPr wrap="square" lIns="25400" tIns="76200" rIns="76200" bIns="25400" rtlCol="0" anchor="ctr"/>
+          <a:lstStyle/>
+          <a:p>
+            <a:pPr algn="ctr" indent="0" marL="0">
+              <a:buNone/>
+            </a:pPr>
+            <a:r>
+              <a:rPr lang="en-US" sz="1000" b="1" dirty="0">
+                <a:solidFill>
+                  <a:srgbClr val="3A243A"/>
+                </a:solidFill>
+                <a:latin typeface="Montserrat" pitchFamily="34" charset="0"/>
+                <a:ea typeface="Montserrat" pitchFamily="34" charset="-122"/>
+                <a:cs typeface="Montserrat" pitchFamily="34" charset="-120"/>
+              </a:rPr>
+              <a:t>Returned at NAV</a:t>
+            </a:r>
+            <a:endParaRPr lang="en-US" sz="1000" dirty="0"/>
+          </a:p>
+        </p:txBody>
+      </p:sp>
+      <p:sp>
+        <p:nvSpPr>
+          <p:cNvPr id="44" name="Shape 42"/>
+          <p:cNvSpPr/>
+          <p:nvPr/>
+        </p:nvSpPr>
+        <p:spPr>
+          <a:xfrm>
+            <a:off x="5394960" y="4764024"/>
+            <a:ext cx="6336792" cy="566928"/>
+          </a:xfrm>
+          <a:prstGeom prst="rect">
+            <a:avLst/>
+          </a:prstGeom>
+          <a:solidFill>
+            <a:srgbClr val="F4F2ED"/>
+          </a:solidFill>
+          <a:ln/>
+        </p:spPr>
+      </p:sp>
+      <p:sp>
+        <p:nvSpPr>
+          <p:cNvPr id="45" name="Text 43"/>
+          <p:cNvSpPr/>
+          <p:nvPr/>
+        </p:nvSpPr>
+        <p:spPr>
+          <a:xfrm>
+            <a:off x="5394960" y="4764024"/>
+            <a:ext cx="6336792" cy="566928"/>
+          </a:xfrm>
+          <a:prstGeom prst="rect">
+            <a:avLst/>
+          </a:prstGeom>
+          <a:noFill/>
+          <a:ln/>
+        </p:spPr>
+        <p:txBody>
+          <a:bodyPr wrap="square" lIns="25400" tIns="76200" rIns="76200" bIns="25400" rtlCol="0" anchor="ctr"/>
+          <a:lstStyle/>
+          <a:p>
+            <a:pPr algn="l" indent="0" marL="0">
+              <a:lnSpc>
+                <a:spcPts val="1200"/>
+              </a:lnSpc>
+              <a:buNone/>
+            </a:pPr>
+            <a:r>
+              <a:rPr lang="en-US" sz="950" dirty="0">
+                <a:solidFill>
+                  <a:srgbClr val="6B5A6B"/>
+                </a:solidFill>
+                <a:latin typeface="DM Sans" pitchFamily="34" charset="0"/>
+                <a:ea typeface="DM Sans" pitchFamily="34" charset="-122"/>
+                <a:cs typeface="DM Sans" pitchFamily="34" charset="-120"/>
+              </a:rPr>
+              <a:t>It's an investment, not comp — returned like any investor's. I don't lose it; it doesn't keep me in the deal.</a:t>
+            </a:r>
+            <a:endParaRPr lang="en-US" sz="950" dirty="0"/>
+          </a:p>
+        </p:txBody>
+      </p:sp>
+      <p:sp>
+        <p:nvSpPr>
+          <p:cNvPr id="46" name="Shape 44"/>
+          <p:cNvSpPr/>
+          <p:nvPr/>
+        </p:nvSpPr>
+        <p:spPr>
+          <a:xfrm>
+            <a:off x="457200" y="5330952"/>
+            <a:ext cx="2331720" cy="566928"/>
+          </a:xfrm>
+          <a:prstGeom prst="rect">
+            <a:avLst/>
+          </a:prstGeom>
+          <a:solidFill>
+            <a:srgbClr val="FFFFFF"/>
+          </a:solidFill>
+          <a:ln/>
+        </p:spPr>
+      </p:sp>
+      <p:sp>
+        <p:nvSpPr>
+          <p:cNvPr id="47" name="Text 45"/>
+          <p:cNvSpPr/>
+          <p:nvPr/>
+        </p:nvSpPr>
+        <p:spPr>
+          <a:xfrm>
+            <a:off x="457200" y="5330952"/>
+            <a:ext cx="2331720" cy="566928"/>
+          </a:xfrm>
+          <a:prstGeom prst="rect">
+            <a:avLst/>
+          </a:prstGeom>
+          <a:noFill/>
+          <a:ln/>
+        </p:spPr>
+        <p:txBody>
+          <a:bodyPr wrap="square" lIns="25400" tIns="76200" rIns="76200" bIns="25400" rtlCol="0" anchor="ctr"/>
+          <a:lstStyle/>
+          <a:p>
+            <a:pPr algn="l" indent="0" marL="0">
+              <a:buNone/>
+            </a:pPr>
+            <a:r>
+              <a:rPr lang="en-US" sz="1100" b="1" dirty="0">
+                <a:solidFill>
+                  <a:srgbClr val="0B163C"/>
+                </a:solidFill>
+                <a:latin typeface="Montserrat" pitchFamily="34" charset="0"/>
+                <a:ea typeface="Montserrat" pitchFamily="34" charset="-122"/>
+                <a:cs typeface="Montserrat" pitchFamily="34" charset="-120"/>
+              </a:rPr>
+              <a:t>Clean break</a:t>
+            </a:r>
+            <a:endParaRPr lang="en-US" sz="1100" dirty="0"/>
+          </a:p>
+        </p:txBody>
+      </p:sp>
+      <p:sp>
+        <p:nvSpPr>
+          <p:cNvPr id="48" name="Shape 46"/>
+          <p:cNvSpPr/>
+          <p:nvPr/>
+        </p:nvSpPr>
+        <p:spPr>
+          <a:xfrm>
+            <a:off x="2788920" y="5330952"/>
+            <a:ext cx="2606040" cy="566928"/>
+          </a:xfrm>
+          <a:prstGeom prst="rect">
+            <a:avLst/>
+          </a:prstGeom>
+          <a:solidFill>
+            <a:srgbClr val="FFFFFF"/>
+          </a:solidFill>
+          <a:ln/>
+        </p:spPr>
+      </p:sp>
+      <p:sp>
+        <p:nvSpPr>
+          <p:cNvPr id="49" name="Text 47"/>
+          <p:cNvSpPr/>
+          <p:nvPr/>
+        </p:nvSpPr>
+        <p:spPr>
+          <a:xfrm>
+            <a:off x="2788920" y="5330952"/>
+            <a:ext cx="2606040" cy="566928"/>
+          </a:xfrm>
+          <a:prstGeom prst="rect">
+            <a:avLst/>
+          </a:prstGeom>
+          <a:noFill/>
+          <a:ln/>
+        </p:spPr>
+        <p:txBody>
+          <a:bodyPr wrap="square" lIns="25400" tIns="76200" rIns="76200" bIns="25400" rtlCol="0" anchor="ctr"/>
+          <a:lstStyle/>
+          <a:p>
+            <a:pPr algn="ctr" indent="0" marL="0">
+              <a:buNone/>
+            </a:pPr>
+            <a:r>
+              <a:rPr lang="en-US" sz="1000" b="1" dirty="0">
+                <a:solidFill>
+                  <a:srgbClr val="3A243A"/>
+                </a:solidFill>
+                <a:latin typeface="Montserrat" pitchFamily="34" charset="0"/>
+                <a:ea typeface="Montserrat" pitchFamily="34" charset="-122"/>
+                <a:cs typeface="Montserrat" pitchFamily="34" charset="-120"/>
+              </a:rPr>
+              <a:t>Optional buyout</a:t>
+            </a:r>
+            <a:endParaRPr lang="en-US" sz="1000" dirty="0"/>
+          </a:p>
+        </p:txBody>
+      </p:sp>
+      <p:sp>
+        <p:nvSpPr>
+          <p:cNvPr id="50" name="Shape 48"/>
+          <p:cNvSpPr/>
+          <p:nvPr/>
+        </p:nvSpPr>
+        <p:spPr>
+          <a:xfrm>
+            <a:off x="5394960" y="5330952"/>
+            <a:ext cx="6336792" cy="566928"/>
+          </a:xfrm>
+          <a:prstGeom prst="rect">
+            <a:avLst/>
+          </a:prstGeom>
+          <a:solidFill>
+            <a:srgbClr val="FFFFFF"/>
+          </a:solidFill>
+          <a:ln/>
+        </p:spPr>
+      </p:sp>
+      <p:sp>
+        <p:nvSpPr>
+          <p:cNvPr id="51" name="Text 49"/>
+          <p:cNvSpPr/>
+          <p:nvPr/>
+        </p:nvSpPr>
+        <p:spPr>
+          <a:xfrm>
+            <a:off x="5394960" y="5330952"/>
+            <a:ext cx="6336792" cy="566928"/>
+          </a:xfrm>
+          <a:prstGeom prst="rect">
+            <a:avLst/>
+          </a:prstGeom>
+          <a:noFill/>
+          <a:ln/>
+        </p:spPr>
+        <p:txBody>
+          <a:bodyPr wrap="square" lIns="25400" tIns="76200" rIns="76200" bIns="25400" rtlCol="0" anchor="ctr"/>
+          <a:lstStyle/>
+          <a:p>
+            <a:pPr algn="l" indent="0" marL="0">
+              <a:lnSpc>
+                <a:spcPts val="1200"/>
+              </a:lnSpc>
+              <a:buNone/>
+            </a:pPr>
+            <a:r>
+              <a:rPr lang="en-US" sz="950" dirty="0">
+                <a:solidFill>
+                  <a:srgbClr val="6B5A6B"/>
+                </a:solidFill>
+                <a:latin typeface="DM Sans" pitchFamily="34" charset="0"/>
+                <a:ea typeface="DM Sans" pitchFamily="34" charset="-122"/>
+                <a:cs typeface="DM Sans" pitchFamily="34" charset="-120"/>
+              </a:rPr>
+              <a:t>I hand over all work product and step out of the dev co. You can buy out my vested carry at a set formula for a fully clean break.</a:t>
+            </a:r>
+            <a:endParaRPr lang="en-US" sz="950" dirty="0"/>
+          </a:p>
+        </p:txBody>
+      </p:sp>
+      <p:sp>
+        <p:nvSpPr>
+          <p:cNvPr id="52" name="Shape 50"/>
+          <p:cNvSpPr/>
+          <p:nvPr/>
+        </p:nvSpPr>
+        <p:spPr>
+          <a:xfrm>
+            <a:off x="457200" y="5943600"/>
+            <a:ext cx="11274552" cy="420624"/>
+          </a:xfrm>
+          <a:prstGeom prst="rect">
+            <a:avLst/>
+          </a:prstGeom>
+          <a:solidFill>
+            <a:srgbClr val="3A243A"/>
+          </a:solidFill>
+          <a:ln/>
+        </p:spPr>
+      </p:sp>
+      <p:sp>
+        <p:nvSpPr>
+          <p:cNvPr id="53" name="Text 51"/>
+          <p:cNvSpPr/>
+          <p:nvPr/>
+        </p:nvSpPr>
+        <p:spPr>
+          <a:xfrm>
+            <a:off x="640080" y="5943600"/>
+            <a:ext cx="10908792" cy="420624"/>
+          </a:xfrm>
+          <a:prstGeom prst="rect">
+            <a:avLst/>
+          </a:prstGeom>
+          <a:noFill/>
+          <a:ln/>
+        </p:spPr>
+        <p:txBody>
+          <a:bodyPr wrap="square" lIns="0" tIns="0" rIns="0" bIns="0" rtlCol="0" anchor="ctr"/>
+          <a:lstStyle/>
+          <a:p>
+            <a:pPr algn="ctr" indent="0" marL="0">
+              <a:buNone/>
+            </a:pPr>
+            <a:r>
+              <a:rPr lang="en-US" sz="1100" b="1" dirty="0">
+                <a:solidFill>
+                  <a:srgbClr val="FFFFFF"/>
+                </a:solidFill>
+                <a:latin typeface="DM Sans" pitchFamily="34" charset="0"/>
+                <a:ea typeface="DM Sans" pitchFamily="34" charset="-122"/>
+                <a:cs typeface="DM Sans" pitchFamily="34" charset="-120"/>
+              </a:rPr>
+              <a:t>You can let me go any time — and only ever owe me for value already created. That's the point of comp that's mostly contingent carry.</a:t>
             </a:r>
             <a:endParaRPr lang="en-US" sz="1100" dirty="0"/>
           </a:p>

</xml_diff>